<commit_message>
Regenerate PDF and PPTX slide deck artifacts with updated SILRAD metrics and scenario holdout results
</commit_message>
<xml_diff>
--- a/docs/BRDS_Project_Presentation.pptx
+++ b/docs/BRDS_Project_Presentation.pptx
@@ -3278,7 +3278,7 @@
               </a:defRPr>
             </a:pPr>
             <a:r>
-              <a:t>Evaluated Performance: 99.71% Validation Accuracy | 100% Recall | 25/25 Passing Unit Tests</a:t>
+              <a:t>Evaluated Performance: 99.51% F1 Score | 93.14% Unseen Attack Generalization | 29/29 Passing Unit Tests</a:t>
             </a:r>
           </a:p>
         </p:txBody>
@@ -4920,7 +4920,7 @@
               </a:defRPr>
             </a:pPr>
             <a:r>
-              <a:t>99.71%</a:t>
+              <a:t>99.51%</a:t>
             </a:r>
           </a:p>
           <a:p>
@@ -4932,7 +4932,7 @@
               </a:defRPr>
             </a:pPr>
             <a:r>
-              <a:t>Validation Accuracy</a:t>
+              <a:t>F1 Score</a:t>
             </a:r>
           </a:p>
           <a:p>
@@ -4944,7 +4944,7 @@
               </a:defRPr>
             </a:pPr>
             <a:r>
-              <a:t>PyTorch LSTM Sequence Model</a:t>
+              <a:t>PyTorch LSTM &amp; Baseline Models</a:t>
             </a:r>
           </a:p>
         </p:txBody>
@@ -4998,7 +4998,7 @@
               </a:defRPr>
             </a:pPr>
             <a:r>
-              <a:t>100.0%</a:t>
+              <a:t>99.48%</a:t>
             </a:r>
           </a:p>
           <a:p>
@@ -5022,7 +5022,7 @@
               </a:defRPr>
             </a:pPr>
             <a:r>
-              <a:t>Zero False Negatives on Attack Windows</a:t>
+              <a:t>Low False Negatives on Attack Windows</a:t>
             </a:r>
           </a:p>
         </p:txBody>
@@ -5076,7 +5076,7 @@
               </a:defRPr>
             </a:pPr>
             <a:r>
-              <a:t>98.69%</a:t>
+              <a:t>97.31%</a:t>
             </a:r>
           </a:p>
           <a:p>
@@ -5088,7 +5088,7 @@
               </a:defRPr>
             </a:pPr>
             <a:r>
-              <a:t>Precision Score</a:t>
+              <a:t>Unseen Precision</a:t>
             </a:r>
           </a:p>
           <a:p>
@@ -5100,7 +5100,7 @@
               </a:defRPr>
             </a:pPr>
             <a:r>
-              <a:t>High Quality Alert Generation</a:t>
+              <a:t>Leave-One-Scenario-Out Cross-Val</a:t>
             </a:r>
           </a:p>
         </p:txBody>
@@ -5154,7 +5154,7 @@
               </a:defRPr>
             </a:pPr>
             <a:r>
-              <a:t>0.988</a:t>
+              <a:t>93.14%</a:t>
             </a:r>
           </a:p>
           <a:p>
@@ -5166,7 +5166,7 @@
               </a:defRPr>
             </a:pPr>
             <a:r>
-              <a:t>ROC-AUC Score</a:t>
+              <a:t>Held-Out F1</a:t>
             </a:r>
           </a:p>
           <a:p>
@@ -5178,7 +5178,7 @@
               </a:defRPr>
             </a:pPr>
             <a:r>
-              <a:t>Excellent Binary Classification</a:t>
+              <a:t>Generalization to Unseen Attack Types</a:t>
             </a:r>
           </a:p>
         </p:txBody>

</xml_diff>